<commit_message>
Deployed 0112d04 with MkDocs version: 1.6.1
</commit_message>
<xml_diff>
--- a/assets/illustrations.pptx
+++ b/assets/illustrations.pptx
@@ -265,7 +265,7 @@
           <a:p>
             <a:fld id="{B6EBD849-BF62-3E41-9392-B52349D77D8A}" type="datetimeFigureOut">
               <a:rPr lang="en-US" smtClean="0"/>
-              <a:t>1/23/26</a:t>
+              <a:t>7/11/26</a:t>
             </a:fld>
             <a:endParaRPr lang="en-US"/>
           </a:p>
@@ -463,7 +463,7 @@
           <a:p>
             <a:fld id="{B6EBD849-BF62-3E41-9392-B52349D77D8A}" type="datetimeFigureOut">
               <a:rPr lang="en-US" smtClean="0"/>
-              <a:t>1/23/26</a:t>
+              <a:t>7/11/26</a:t>
             </a:fld>
             <a:endParaRPr lang="en-US"/>
           </a:p>
@@ -671,7 +671,7 @@
           <a:p>
             <a:fld id="{B6EBD849-BF62-3E41-9392-B52349D77D8A}" type="datetimeFigureOut">
               <a:rPr lang="en-US" smtClean="0"/>
-              <a:t>1/23/26</a:t>
+              <a:t>7/11/26</a:t>
             </a:fld>
             <a:endParaRPr lang="en-US"/>
           </a:p>
@@ -869,7 +869,7 @@
           <a:p>
             <a:fld id="{B6EBD849-BF62-3E41-9392-B52349D77D8A}" type="datetimeFigureOut">
               <a:rPr lang="en-US" smtClean="0"/>
-              <a:t>1/23/26</a:t>
+              <a:t>7/11/26</a:t>
             </a:fld>
             <a:endParaRPr lang="en-US"/>
           </a:p>
@@ -1144,7 +1144,7 @@
           <a:p>
             <a:fld id="{B6EBD849-BF62-3E41-9392-B52349D77D8A}" type="datetimeFigureOut">
               <a:rPr lang="en-US" smtClean="0"/>
-              <a:t>1/23/26</a:t>
+              <a:t>7/11/26</a:t>
             </a:fld>
             <a:endParaRPr lang="en-US"/>
           </a:p>
@@ -1409,7 +1409,7 @@
           <a:p>
             <a:fld id="{B6EBD849-BF62-3E41-9392-B52349D77D8A}" type="datetimeFigureOut">
               <a:rPr lang="en-US" smtClean="0"/>
-              <a:t>1/23/26</a:t>
+              <a:t>7/11/26</a:t>
             </a:fld>
             <a:endParaRPr lang="en-US"/>
           </a:p>
@@ -1821,7 +1821,7 @@
           <a:p>
             <a:fld id="{B6EBD849-BF62-3E41-9392-B52349D77D8A}" type="datetimeFigureOut">
               <a:rPr lang="en-US" smtClean="0"/>
-              <a:t>1/23/26</a:t>
+              <a:t>7/11/26</a:t>
             </a:fld>
             <a:endParaRPr lang="en-US"/>
           </a:p>
@@ -1962,7 +1962,7 @@
           <a:p>
             <a:fld id="{B6EBD849-BF62-3E41-9392-B52349D77D8A}" type="datetimeFigureOut">
               <a:rPr lang="en-US" smtClean="0"/>
-              <a:t>1/23/26</a:t>
+              <a:t>7/11/26</a:t>
             </a:fld>
             <a:endParaRPr lang="en-US"/>
           </a:p>
@@ -2075,7 +2075,7 @@
           <a:p>
             <a:fld id="{B6EBD849-BF62-3E41-9392-B52349D77D8A}" type="datetimeFigureOut">
               <a:rPr lang="en-US" smtClean="0"/>
-              <a:t>1/23/26</a:t>
+              <a:t>7/11/26</a:t>
             </a:fld>
             <a:endParaRPr lang="en-US"/>
           </a:p>
@@ -2386,7 +2386,7 @@
           <a:p>
             <a:fld id="{B6EBD849-BF62-3E41-9392-B52349D77D8A}" type="datetimeFigureOut">
               <a:rPr lang="en-US" smtClean="0"/>
-              <a:t>1/23/26</a:t>
+              <a:t>7/11/26</a:t>
             </a:fld>
             <a:endParaRPr lang="en-US"/>
           </a:p>
@@ -2674,7 +2674,7 @@
           <a:p>
             <a:fld id="{B6EBD849-BF62-3E41-9392-B52349D77D8A}" type="datetimeFigureOut">
               <a:rPr lang="en-US" smtClean="0"/>
-              <a:t>1/23/26</a:t>
+              <a:t>7/11/26</a:t>
             </a:fld>
             <a:endParaRPr lang="en-US"/>
           </a:p>
@@ -2915,7 +2915,7 @@
           <a:p>
             <a:fld id="{B6EBD849-BF62-3E41-9392-B52349D77D8A}" type="datetimeFigureOut">
               <a:rPr lang="en-US" smtClean="0"/>
-              <a:t>1/23/26</a:t>
+              <a:t>7/11/26</a:t>
             </a:fld>
             <a:endParaRPr lang="en-US"/>
           </a:p>
@@ -3401,10 +3401,10 @@
           <p:nvPr/>
         </p:nvPicPr>
         <p:blipFill>
-          <a:blip r:embed="rId2">
+          <a:blip>
             <a:extLst>
               <a:ext uri="{96DAC541-7B7A-43D3-8B79-37D633B846F1}">
-                <asvg:svgBlip xmlns:asvg="http://schemas.microsoft.com/office/drawing/2016/SVG/main" r:embed="rId3"/>
+                <asvg:svgBlip xmlns:asvg="http://schemas.microsoft.com/office/drawing/2016/SVG/main" r:embed="rId2"/>
               </a:ext>
             </a:extLst>
           </a:blip>
@@ -3478,10 +3478,10 @@
           <p:nvPr/>
         </p:nvPicPr>
         <p:blipFill>
-          <a:blip r:embed="rId4">
+          <a:blip>
             <a:extLst>
               <a:ext uri="{96DAC541-7B7A-43D3-8B79-37D633B846F1}">
-                <asvg:svgBlip xmlns:asvg="http://schemas.microsoft.com/office/drawing/2016/SVG/main" r:embed="rId5"/>
+                <asvg:svgBlip xmlns:asvg="http://schemas.microsoft.com/office/drawing/2016/SVG/main" r:embed="rId3"/>
               </a:ext>
             </a:extLst>
           </a:blip>
@@ -3514,10 +3514,10 @@
           <p:nvPr/>
         </p:nvPicPr>
         <p:blipFill>
-          <a:blip r:embed="rId6">
+          <a:blip>
             <a:extLst>
               <a:ext uri="{96DAC541-7B7A-43D3-8B79-37D633B846F1}">
-                <asvg:svgBlip xmlns:asvg="http://schemas.microsoft.com/office/drawing/2016/SVG/main" r:embed="rId7"/>
+                <asvg:svgBlip xmlns:asvg="http://schemas.microsoft.com/office/drawing/2016/SVG/main" r:embed="rId4"/>
               </a:ext>
             </a:extLst>
           </a:blip>
@@ -3550,10 +3550,10 @@
           <p:nvPr/>
         </p:nvPicPr>
         <p:blipFill>
-          <a:blip r:embed="rId8">
+          <a:blip>
             <a:extLst>
               <a:ext uri="{96DAC541-7B7A-43D3-8B79-37D633B846F1}">
-                <asvg:svgBlip xmlns:asvg="http://schemas.microsoft.com/office/drawing/2016/SVG/main" r:embed="rId9"/>
+                <asvg:svgBlip xmlns:asvg="http://schemas.microsoft.com/office/drawing/2016/SVG/main" r:embed="rId5"/>
               </a:ext>
             </a:extLst>
           </a:blip>
@@ -3586,10 +3586,10 @@
           <p:nvPr/>
         </p:nvPicPr>
         <p:blipFill>
-          <a:blip r:embed="rId10">
+          <a:blip>
             <a:extLst>
               <a:ext uri="{96DAC541-7B7A-43D3-8B79-37D633B846F1}">
-                <asvg:svgBlip xmlns:asvg="http://schemas.microsoft.com/office/drawing/2016/SVG/main" r:embed="rId11"/>
+                <asvg:svgBlip xmlns:asvg="http://schemas.microsoft.com/office/drawing/2016/SVG/main" r:embed="rId6"/>
               </a:ext>
             </a:extLst>
           </a:blip>
@@ -3622,10 +3622,10 @@
           <p:nvPr/>
         </p:nvPicPr>
         <p:blipFill>
-          <a:blip r:embed="rId10">
+          <a:blip>
             <a:extLst>
               <a:ext uri="{96DAC541-7B7A-43D3-8B79-37D633B846F1}">
-                <asvg:svgBlip xmlns:asvg="http://schemas.microsoft.com/office/drawing/2016/SVG/main" r:embed="rId11"/>
+                <asvg:svgBlip xmlns:asvg="http://schemas.microsoft.com/office/drawing/2016/SVG/main" r:embed="rId6"/>
               </a:ext>
             </a:extLst>
           </a:blip>
@@ -3878,10 +3878,10 @@
           <p:nvPr/>
         </p:nvPicPr>
         <p:blipFill>
-          <a:blip r:embed="rId12">
+          <a:blip>
             <a:extLst>
               <a:ext uri="{96DAC541-7B7A-43D3-8B79-37D633B846F1}">
-                <asvg:svgBlip xmlns:asvg="http://schemas.microsoft.com/office/drawing/2016/SVG/main" r:embed="rId13"/>
+                <asvg:svgBlip xmlns:asvg="http://schemas.microsoft.com/office/drawing/2016/SVG/main" r:embed="rId7"/>
               </a:ext>
             </a:extLst>
           </a:blip>
@@ -3914,10 +3914,10 @@
           <p:nvPr/>
         </p:nvPicPr>
         <p:blipFill>
-          <a:blip r:embed="rId12">
+          <a:blip>
             <a:extLst>
               <a:ext uri="{96DAC541-7B7A-43D3-8B79-37D633B846F1}">
-                <asvg:svgBlip xmlns:asvg="http://schemas.microsoft.com/office/drawing/2016/SVG/main" r:embed="rId13"/>
+                <asvg:svgBlip xmlns:asvg="http://schemas.microsoft.com/office/drawing/2016/SVG/main" r:embed="rId7"/>
               </a:ext>
             </a:extLst>
           </a:blip>
@@ -4125,8 +4125,8 @@
         </p:nvSpPr>
         <p:spPr>
           <a:xfrm>
-            <a:off x="4400707" y="1063492"/>
-            <a:ext cx="1936376" cy="369332"/>
+            <a:off x="4195428" y="1079500"/>
+            <a:ext cx="2346934" cy="369332"/>
           </a:xfrm>
           <a:prstGeom prst="rect">
             <a:avLst/>
@@ -4147,7 +4147,7 @@
                 </a:solidFill>
                 <a:latin typeface="Avenir Book" panose="02000503020000020003" pitchFamily="2" charset="0"/>
               </a:rPr>
-              <a:t>Your Web Server</a:t>
+              <a:t>Your Product BFF</a:t>
             </a:r>
           </a:p>
         </p:txBody>
@@ -4312,10 +4312,10 @@
           <p:nvPr/>
         </p:nvPicPr>
         <p:blipFill>
-          <a:blip r:embed="rId2">
+          <a:blip>
             <a:extLst>
               <a:ext uri="{96DAC541-7B7A-43D3-8B79-37D633B846F1}">
-                <asvg:svgBlip xmlns:asvg="http://schemas.microsoft.com/office/drawing/2016/SVG/main" r:embed="rId3"/>
+                <asvg:svgBlip xmlns:asvg="http://schemas.microsoft.com/office/drawing/2016/SVG/main" r:embed="rId2"/>
               </a:ext>
             </a:extLst>
           </a:blip>
@@ -4348,10 +4348,10 @@
           <p:nvPr/>
         </p:nvPicPr>
         <p:blipFill>
-          <a:blip r:embed="rId4">
+          <a:blip>
             <a:extLst>
               <a:ext uri="{96DAC541-7B7A-43D3-8B79-37D633B846F1}">
-                <asvg:svgBlip xmlns:asvg="http://schemas.microsoft.com/office/drawing/2016/SVG/main" r:embed="rId5"/>
+                <asvg:svgBlip xmlns:asvg="http://schemas.microsoft.com/office/drawing/2016/SVG/main" r:embed="rId3"/>
               </a:ext>
             </a:extLst>
           </a:blip>
@@ -4384,10 +4384,10 @@
           <p:nvPr/>
         </p:nvPicPr>
         <p:blipFill>
-          <a:blip r:embed="rId6">
+          <a:blip>
             <a:extLst>
               <a:ext uri="{96DAC541-7B7A-43D3-8B79-37D633B846F1}">
-                <asvg:svgBlip xmlns:asvg="http://schemas.microsoft.com/office/drawing/2016/SVG/main" r:embed="rId7"/>
+                <asvg:svgBlip xmlns:asvg="http://schemas.microsoft.com/office/drawing/2016/SVG/main" r:embed="rId4"/>
               </a:ext>
             </a:extLst>
           </a:blip>
@@ -4420,10 +4420,10 @@
           <p:nvPr/>
         </p:nvPicPr>
         <p:blipFill>
-          <a:blip r:embed="rId8">
+          <a:blip>
             <a:extLst>
               <a:ext uri="{96DAC541-7B7A-43D3-8B79-37D633B846F1}">
-                <asvg:svgBlip xmlns:asvg="http://schemas.microsoft.com/office/drawing/2016/SVG/main" r:embed="rId9"/>
+                <asvg:svgBlip xmlns:asvg="http://schemas.microsoft.com/office/drawing/2016/SVG/main" r:embed="rId5"/>
               </a:ext>
             </a:extLst>
           </a:blip>
@@ -4456,10 +4456,10 @@
           <p:nvPr/>
         </p:nvPicPr>
         <p:blipFill>
-          <a:blip r:embed="rId8">
+          <a:blip>
             <a:extLst>
               <a:ext uri="{96DAC541-7B7A-43D3-8B79-37D633B846F1}">
-                <asvg:svgBlip xmlns:asvg="http://schemas.microsoft.com/office/drawing/2016/SVG/main" r:embed="rId9"/>
+                <asvg:svgBlip xmlns:asvg="http://schemas.microsoft.com/office/drawing/2016/SVG/main" r:embed="rId5"/>
               </a:ext>
             </a:extLst>
           </a:blip>
@@ -4668,7 +4668,7 @@
         </p:nvCxnSpPr>
         <p:spPr>
           <a:xfrm>
-            <a:off x="9186530" y="2501355"/>
+            <a:off x="9186530" y="2655305"/>
             <a:ext cx="691117" cy="0"/>
           </a:xfrm>
           <a:prstGeom prst="straightConnector1">
@@ -4712,10 +4712,10 @@
           <p:nvPr/>
         </p:nvPicPr>
         <p:blipFill>
-          <a:blip r:embed="rId10">
+          <a:blip>
             <a:extLst>
               <a:ext uri="{96DAC541-7B7A-43D3-8B79-37D633B846F1}">
-                <asvg:svgBlip xmlns:asvg="http://schemas.microsoft.com/office/drawing/2016/SVG/main" r:embed="rId11"/>
+                <asvg:svgBlip xmlns:asvg="http://schemas.microsoft.com/office/drawing/2016/SVG/main" r:embed="rId6"/>
               </a:ext>
             </a:extLst>
           </a:blip>
@@ -4748,10 +4748,10 @@
           <p:nvPr/>
         </p:nvPicPr>
         <p:blipFill>
-          <a:blip r:embed="rId10">
+          <a:blip>
             <a:extLst>
               <a:ext uri="{96DAC541-7B7A-43D3-8B79-37D633B846F1}">
-                <asvg:svgBlip xmlns:asvg="http://schemas.microsoft.com/office/drawing/2016/SVG/main" r:embed="rId11"/>
+                <asvg:svgBlip xmlns:asvg="http://schemas.microsoft.com/office/drawing/2016/SVG/main" r:embed="rId6"/>
               </a:ext>
             </a:extLst>
           </a:blip>
@@ -4960,7 +4960,7 @@
         <p:spPr>
           <a:xfrm>
             <a:off x="4400707" y="1797145"/>
-            <a:ext cx="1936376" cy="369332"/>
+            <a:ext cx="1936376" cy="276999"/>
           </a:xfrm>
           <a:prstGeom prst="rect">
             <a:avLst/>
@@ -4975,7 +4975,7 @@
           <a:p>
             <a:pPr algn="ctr"/>
             <a:r>
-              <a:rPr lang="en-US" dirty="0">
+              <a:rPr lang="en-US" sz="1200" dirty="0">
                 <a:solidFill>
                   <a:schemeClr val="bg1"/>
                 </a:solidFill>
@@ -5051,12 +5051,132 @@
           </a:p>
         </p:txBody>
       </p:sp>
-      <p:sp>
-        <p:nvSpPr>
-          <p:cNvPr id="9" name="Rounded Rectangle 8">
-            <a:extLst>
-              <a:ext uri="{FF2B5EF4-FFF2-40B4-BE49-F238E27FC236}">
-                <a16:creationId xmlns:a16="http://schemas.microsoft.com/office/drawing/2014/main" id="{3473AE74-70CF-8DBB-9A11-737D27173566}"/>
+      <p:cxnSp>
+        <p:nvCxnSpPr>
+          <p:cNvPr id="21" name="Straight Arrow Connector 20">
+            <a:extLst>
+              <a:ext uri="{FF2B5EF4-FFF2-40B4-BE49-F238E27FC236}">
+                <a16:creationId xmlns:a16="http://schemas.microsoft.com/office/drawing/2014/main" id="{F3B1EEF8-D976-3222-1850-BD993F1C4B63}"/>
+              </a:ext>
+            </a:extLst>
+          </p:cNvPr>
+          <p:cNvCxnSpPr/>
+          <p:nvPr/>
+        </p:nvCxnSpPr>
+        <p:spPr>
+          <a:xfrm>
+            <a:off x="2048438" y="2676433"/>
+            <a:ext cx="2701892" cy="0"/>
+          </a:xfrm>
+          <a:prstGeom prst="straightConnector1">
+            <a:avLst/>
+          </a:prstGeom>
+          <a:ln>
+            <a:solidFill>
+              <a:schemeClr val="bg1"/>
+            </a:solidFill>
+            <a:headEnd type="triangle"/>
+            <a:tailEnd type="triangle"/>
+          </a:ln>
+        </p:spPr>
+        <p:style>
+          <a:lnRef idx="2">
+            <a:schemeClr val="accent1"/>
+          </a:lnRef>
+          <a:fillRef idx="0">
+            <a:schemeClr val="accent1"/>
+          </a:fillRef>
+          <a:effectRef idx="1">
+            <a:schemeClr val="accent1"/>
+          </a:effectRef>
+          <a:fontRef idx="minor">
+            <a:schemeClr val="tx1"/>
+          </a:fontRef>
+        </p:style>
+      </p:cxnSp>
+      <p:pic>
+        <p:nvPicPr>
+          <p:cNvPr id="23" name="Graphic 22" descr="Ui Ux with solid fill">
+            <a:extLst>
+              <a:ext uri="{FF2B5EF4-FFF2-40B4-BE49-F238E27FC236}">
+                <a16:creationId xmlns:a16="http://schemas.microsoft.com/office/drawing/2014/main" id="{7585C4C5-A7E8-8C9B-DAC3-F27498D39667}"/>
+              </a:ext>
+            </a:extLst>
+          </p:cNvPr>
+          <p:cNvPicPr>
+            <a:picLocks noChangeAspect="1"/>
+          </p:cNvPicPr>
+          <p:nvPr/>
+        </p:nvPicPr>
+        <p:blipFill>
+          <a:blip>
+            <a:extLst>
+              <a:ext uri="{96DAC541-7B7A-43D3-8B79-37D633B846F1}">
+                <asvg:svgBlip xmlns:asvg="http://schemas.microsoft.com/office/drawing/2016/SVG/main" r:embed="rId7"/>
+              </a:ext>
+            </a:extLst>
+          </a:blip>
+          <a:stretch>
+            <a:fillRect/>
+          </a:stretch>
+        </p:blipFill>
+        <p:spPr>
+          <a:xfrm>
+            <a:off x="590705" y="2095009"/>
+            <a:ext cx="1237130" cy="1237130"/>
+          </a:xfrm>
+          <a:prstGeom prst="rect">
+            <a:avLst/>
+          </a:prstGeom>
+        </p:spPr>
+      </p:pic>
+      <p:sp>
+        <p:nvSpPr>
+          <p:cNvPr id="28" name="TextBox 27">
+            <a:extLst>
+              <a:ext uri="{FF2B5EF4-FFF2-40B4-BE49-F238E27FC236}">
+                <a16:creationId xmlns:a16="http://schemas.microsoft.com/office/drawing/2014/main" id="{5F3F082B-58F4-B7B2-9447-C2211B32FB7C}"/>
+              </a:ext>
+            </a:extLst>
+          </p:cNvPr>
+          <p:cNvSpPr txBox="1"/>
+          <p:nvPr/>
+        </p:nvSpPr>
+        <p:spPr>
+          <a:xfrm>
+            <a:off x="241082" y="3294997"/>
+            <a:ext cx="1936376" cy="276999"/>
+          </a:xfrm>
+          <a:prstGeom prst="rect">
+            <a:avLst/>
+          </a:prstGeom>
+          <a:noFill/>
+        </p:spPr>
+        <p:txBody>
+          <a:bodyPr wrap="square" rtlCol="0">
+            <a:spAutoFit/>
+          </a:bodyPr>
+          <a:lstStyle/>
+          <a:p>
+            <a:pPr algn="ctr"/>
+            <a:r>
+              <a:rPr lang="en-US" sz="1200" dirty="0">
+                <a:solidFill>
+                  <a:schemeClr val="bg1"/>
+                </a:solidFill>
+                <a:latin typeface="Avenir Book" panose="02000503020000020003" pitchFamily="2" charset="0"/>
+              </a:rPr>
+              <a:t>Your Product UI</a:t>
+            </a:r>
+          </a:p>
+        </p:txBody>
+      </p:sp>
+      <p:sp>
+        <p:nvSpPr>
+          <p:cNvPr id="29" name="Rounded Rectangle 28">
+            <a:extLst>
+              <a:ext uri="{FF2B5EF4-FFF2-40B4-BE49-F238E27FC236}">
+                <a16:creationId xmlns:a16="http://schemas.microsoft.com/office/drawing/2014/main" id="{5F2C60D7-94D4-FB7B-FC32-EDE8E37E900C}"/>
               </a:ext>
             </a:extLst>
           </p:cNvPr>
@@ -5065,11 +5185,13 @@
         </p:nvSpPr>
         <p:spPr>
           <a:xfrm>
-            <a:off x="7455747" y="445702"/>
-            <a:ext cx="1380618" cy="662275"/>
+            <a:off x="7276915" y="1762873"/>
+            <a:ext cx="1757193" cy="1479801"/>
           </a:xfrm>
           <a:prstGeom prst="roundRect">
-            <a:avLst/>
+            <a:avLst>
+              <a:gd name="adj" fmla="val 6608"/>
+            </a:avLst>
           </a:prstGeom>
           <a:noFill/>
           <a:ln>
@@ -5102,194 +5224,23 @@
           <a:lstStyle/>
           <a:p>
             <a:pPr algn="ctr"/>
-            <a:r>
-              <a:rPr lang="en-US" dirty="0">
-                <a:solidFill>
-                  <a:schemeClr val="tx2">
-                    <a:lumMod val="25000"/>
-                    <a:lumOff val="75000"/>
-                  </a:schemeClr>
-                </a:solidFill>
-              </a:rPr>
-              <a:t>Xians Dev Portal</a:t>
-            </a:r>
-          </a:p>
-        </p:txBody>
-      </p:sp>
-      <p:cxnSp>
-        <p:nvCxnSpPr>
-          <p:cNvPr id="11" name="Straight Arrow Connector 10">
-            <a:extLst>
-              <a:ext uri="{FF2B5EF4-FFF2-40B4-BE49-F238E27FC236}">
-                <a16:creationId xmlns:a16="http://schemas.microsoft.com/office/drawing/2014/main" id="{71EFD1D8-E3BA-C484-7A4B-6E8BDBFECEEE}"/>
-              </a:ext>
-            </a:extLst>
-          </p:cNvPr>
-          <p:cNvCxnSpPr>
-            <a:cxnSpLocks/>
-          </p:cNvCxnSpPr>
-          <p:nvPr/>
-        </p:nvCxnSpPr>
-        <p:spPr>
-          <a:xfrm>
-            <a:off x="8142838" y="1191551"/>
-            <a:ext cx="0" cy="483541"/>
-          </a:xfrm>
-          <a:prstGeom prst="straightConnector1">
-            <a:avLst/>
-          </a:prstGeom>
-          <a:ln>
-            <a:solidFill>
-              <a:schemeClr val="tx2">
-                <a:lumMod val="25000"/>
-                <a:lumOff val="75000"/>
-              </a:schemeClr>
-            </a:solidFill>
-            <a:headEnd type="triangle"/>
-            <a:tailEnd type="triangle"/>
-          </a:ln>
-        </p:spPr>
-        <p:style>
-          <a:lnRef idx="2">
-            <a:schemeClr val="accent1"/>
-          </a:lnRef>
-          <a:fillRef idx="0">
-            <a:schemeClr val="accent1"/>
-          </a:fillRef>
-          <a:effectRef idx="1">
-            <a:schemeClr val="accent1"/>
-          </a:effectRef>
-          <a:fontRef idx="minor">
-            <a:schemeClr val="tx1"/>
-          </a:fontRef>
-        </p:style>
-      </p:cxnSp>
-      <p:cxnSp>
-        <p:nvCxnSpPr>
-          <p:cNvPr id="21" name="Straight Arrow Connector 20">
-            <a:extLst>
-              <a:ext uri="{FF2B5EF4-FFF2-40B4-BE49-F238E27FC236}">
-                <a16:creationId xmlns:a16="http://schemas.microsoft.com/office/drawing/2014/main" id="{F3B1EEF8-D976-3222-1850-BD993F1C4B63}"/>
-              </a:ext>
-            </a:extLst>
-          </p:cNvPr>
-          <p:cNvCxnSpPr/>
-          <p:nvPr/>
-        </p:nvCxnSpPr>
-        <p:spPr>
-          <a:xfrm>
-            <a:off x="2048438" y="2676433"/>
-            <a:ext cx="2701892" cy="0"/>
-          </a:xfrm>
-          <a:prstGeom prst="straightConnector1">
-            <a:avLst/>
-          </a:prstGeom>
-          <a:ln>
-            <a:solidFill>
-              <a:schemeClr val="bg1"/>
-            </a:solidFill>
-            <a:headEnd type="triangle"/>
-            <a:tailEnd type="triangle"/>
-          </a:ln>
-        </p:spPr>
-        <p:style>
-          <a:lnRef idx="2">
-            <a:schemeClr val="accent1"/>
-          </a:lnRef>
-          <a:fillRef idx="0">
-            <a:schemeClr val="accent1"/>
-          </a:fillRef>
-          <a:effectRef idx="1">
-            <a:schemeClr val="accent1"/>
-          </a:effectRef>
-          <a:fontRef idx="minor">
-            <a:schemeClr val="tx1"/>
-          </a:fontRef>
-        </p:style>
-      </p:cxnSp>
-      <p:pic>
-        <p:nvPicPr>
-          <p:cNvPr id="23" name="Graphic 22" descr="Ui Ux with solid fill">
-            <a:extLst>
-              <a:ext uri="{FF2B5EF4-FFF2-40B4-BE49-F238E27FC236}">
-                <a16:creationId xmlns:a16="http://schemas.microsoft.com/office/drawing/2014/main" id="{7585C4C5-A7E8-8C9B-DAC3-F27498D39667}"/>
-              </a:ext>
-            </a:extLst>
-          </p:cNvPr>
-          <p:cNvPicPr>
-            <a:picLocks noChangeAspect="1"/>
-          </p:cNvPicPr>
-          <p:nvPr/>
-        </p:nvPicPr>
-        <p:blipFill>
-          <a:blip r:embed="rId12">
-            <a:extLst>
-              <a:ext uri="{96DAC541-7B7A-43D3-8B79-37D633B846F1}">
-                <asvg:svgBlip xmlns:asvg="http://schemas.microsoft.com/office/drawing/2016/SVG/main" r:embed="rId13"/>
-              </a:ext>
-            </a:extLst>
-          </a:blip>
-          <a:stretch>
-            <a:fillRect/>
-          </a:stretch>
-        </p:blipFill>
-        <p:spPr>
-          <a:xfrm>
-            <a:off x="590705" y="2095009"/>
-            <a:ext cx="1237130" cy="1237130"/>
-          </a:xfrm>
-          <a:prstGeom prst="rect">
-            <a:avLst/>
-          </a:prstGeom>
-        </p:spPr>
-      </p:pic>
-      <p:sp>
-        <p:nvSpPr>
-          <p:cNvPr id="28" name="TextBox 27">
-            <a:extLst>
-              <a:ext uri="{FF2B5EF4-FFF2-40B4-BE49-F238E27FC236}">
-                <a16:creationId xmlns:a16="http://schemas.microsoft.com/office/drawing/2014/main" id="{5F3F082B-58F4-B7B2-9447-C2211B32FB7C}"/>
-              </a:ext>
-            </a:extLst>
-          </p:cNvPr>
-          <p:cNvSpPr txBox="1"/>
-          <p:nvPr/>
-        </p:nvSpPr>
-        <p:spPr>
-          <a:xfrm>
-            <a:off x="241082" y="3294997"/>
-            <a:ext cx="1936376" cy="276999"/>
-          </a:xfrm>
-          <a:prstGeom prst="rect">
-            <a:avLst/>
-          </a:prstGeom>
-          <a:noFill/>
-        </p:spPr>
-        <p:txBody>
-          <a:bodyPr wrap="square" rtlCol="0">
-            <a:spAutoFit/>
-          </a:bodyPr>
-          <a:lstStyle/>
-          <a:p>
-            <a:pPr algn="ctr"/>
-            <a:r>
-              <a:rPr lang="en-US" sz="1200" dirty="0">
-                <a:solidFill>
-                  <a:schemeClr val="bg1"/>
-                </a:solidFill>
-                <a:latin typeface="Avenir Book" panose="02000503020000020003" pitchFamily="2" charset="0"/>
-              </a:rPr>
-              <a:t>Your Product UI</a:t>
-            </a:r>
-          </a:p>
-        </p:txBody>
-      </p:sp>
-      <p:sp>
-        <p:nvSpPr>
-          <p:cNvPr id="29" name="Rounded Rectangle 28">
-            <a:extLst>
-              <a:ext uri="{FF2B5EF4-FFF2-40B4-BE49-F238E27FC236}">
-                <a16:creationId xmlns:a16="http://schemas.microsoft.com/office/drawing/2014/main" id="{5F2C60D7-94D4-FB7B-FC32-EDE8E37E900C}"/>
+            <a:endParaRPr lang="en-US" dirty="0">
+              <a:solidFill>
+                <a:schemeClr val="tx2">
+                  <a:lumMod val="25000"/>
+                  <a:lumOff val="75000"/>
+                </a:schemeClr>
+              </a:solidFill>
+            </a:endParaRPr>
+          </a:p>
+        </p:txBody>
+      </p:sp>
+      <p:sp>
+        <p:nvSpPr>
+          <p:cNvPr id="2" name="Rounded Rectangle 1">
+            <a:extLst>
+              <a:ext uri="{FF2B5EF4-FFF2-40B4-BE49-F238E27FC236}">
+                <a16:creationId xmlns:a16="http://schemas.microsoft.com/office/drawing/2014/main" id="{2AF94583-50B7-15DF-FF90-51C9C688B054}"/>
               </a:ext>
             </a:extLst>
           </p:cNvPr>
@@ -5298,13 +5249,11 @@
         </p:nvSpPr>
         <p:spPr>
           <a:xfrm>
-            <a:off x="7276915" y="1762873"/>
-            <a:ext cx="1757193" cy="1479801"/>
+            <a:off x="527440" y="445701"/>
+            <a:ext cx="1586753" cy="662275"/>
           </a:xfrm>
           <a:prstGeom prst="roundRect">
-            <a:avLst>
-              <a:gd name="adj" fmla="val 6608"/>
-            </a:avLst>
+            <a:avLst/>
           </a:prstGeom>
           <a:noFill/>
           <a:ln>
@@ -5337,68 +5286,6 @@
           <a:lstStyle/>
           <a:p>
             <a:pPr algn="ctr"/>
-            <a:endParaRPr lang="en-US" dirty="0">
-              <a:solidFill>
-                <a:schemeClr val="tx2">
-                  <a:lumMod val="25000"/>
-                  <a:lumOff val="75000"/>
-                </a:schemeClr>
-              </a:solidFill>
-            </a:endParaRPr>
-          </a:p>
-        </p:txBody>
-      </p:sp>
-      <p:sp>
-        <p:nvSpPr>
-          <p:cNvPr id="2" name="Rounded Rectangle 1">
-            <a:extLst>
-              <a:ext uri="{FF2B5EF4-FFF2-40B4-BE49-F238E27FC236}">
-                <a16:creationId xmlns:a16="http://schemas.microsoft.com/office/drawing/2014/main" id="{2AF94583-50B7-15DF-FF90-51C9C688B054}"/>
-              </a:ext>
-            </a:extLst>
-          </p:cNvPr>
-          <p:cNvSpPr/>
-          <p:nvPr/>
-        </p:nvSpPr>
-        <p:spPr>
-          <a:xfrm>
-            <a:off x="527440" y="445701"/>
-            <a:ext cx="1586753" cy="662275"/>
-          </a:xfrm>
-          <a:prstGeom prst="roundRect">
-            <a:avLst/>
-          </a:prstGeom>
-          <a:noFill/>
-          <a:ln>
-            <a:solidFill>
-              <a:schemeClr val="tx2">
-                <a:lumMod val="25000"/>
-                <a:lumOff val="75000"/>
-              </a:schemeClr>
-            </a:solidFill>
-          </a:ln>
-        </p:spPr>
-        <p:style>
-          <a:lnRef idx="2">
-            <a:schemeClr val="accent1">
-              <a:shade val="15000"/>
-            </a:schemeClr>
-          </a:lnRef>
-          <a:fillRef idx="1">
-            <a:schemeClr val="accent1"/>
-          </a:fillRef>
-          <a:effectRef idx="0">
-            <a:schemeClr val="accent1"/>
-          </a:effectRef>
-          <a:fontRef idx="minor">
-            <a:schemeClr val="lt1"/>
-          </a:fontRef>
-        </p:style>
-        <p:txBody>
-          <a:bodyPr rtlCol="0" anchor="ctr"/>
-          <a:lstStyle/>
-          <a:p>
-            <a:pPr algn="ctr"/>
             <a:r>
               <a:rPr lang="en-US" dirty="0">
                 <a:solidFill>
@@ -5483,11 +5370,11 @@
         <p:spPr>
           <a:xfrm>
             <a:off x="2352720" y="767110"/>
-            <a:ext cx="4771773" cy="1384248"/>
+            <a:ext cx="4707299" cy="1399367"/>
           </a:xfrm>
           <a:prstGeom prst="bentConnector3">
             <a:avLst>
-              <a:gd name="adj1" fmla="val 90776"/>
+              <a:gd name="adj1" fmla="val 86171"/>
             </a:avLst>
           </a:prstGeom>
           <a:ln>
@@ -5968,10 +5855,10 @@
           <p:nvPr/>
         </p:nvPicPr>
         <p:blipFill>
-          <a:blip r:embed="rId2">
+          <a:blip>
             <a:extLst>
               <a:ext uri="{96DAC541-7B7A-43D3-8B79-37D633B846F1}">
-                <asvg:svgBlip xmlns:asvg="http://schemas.microsoft.com/office/drawing/2016/SVG/main" r:embed="rId3"/>
+                <asvg:svgBlip xmlns:asvg="http://schemas.microsoft.com/office/drawing/2016/SVG/main" r:embed="rId2"/>
               </a:ext>
             </a:extLst>
           </a:blip>
@@ -6004,10 +5891,10 @@
           <p:nvPr/>
         </p:nvPicPr>
         <p:blipFill>
-          <a:blip r:embed="rId4">
+          <a:blip>
             <a:extLst>
               <a:ext uri="{96DAC541-7B7A-43D3-8B79-37D633B846F1}">
-                <asvg:svgBlip xmlns:asvg="http://schemas.microsoft.com/office/drawing/2016/SVG/main" r:embed="rId5"/>
+                <asvg:svgBlip xmlns:asvg="http://schemas.microsoft.com/office/drawing/2016/SVG/main" r:embed="rId3"/>
               </a:ext>
             </a:extLst>
           </a:blip>
@@ -6040,10 +5927,10 @@
           <p:nvPr/>
         </p:nvPicPr>
         <p:blipFill>
-          <a:blip r:embed="rId6">
+          <a:blip>
             <a:extLst>
               <a:ext uri="{96DAC541-7B7A-43D3-8B79-37D633B846F1}">
-                <asvg:svgBlip xmlns:asvg="http://schemas.microsoft.com/office/drawing/2016/SVG/main" r:embed="rId7"/>
+                <asvg:svgBlip xmlns:asvg="http://schemas.microsoft.com/office/drawing/2016/SVG/main" r:embed="rId4"/>
               </a:ext>
             </a:extLst>
           </a:blip>
@@ -6552,10 +6439,10 @@
           <p:nvPr/>
         </p:nvPicPr>
         <p:blipFill>
-          <a:blip r:embed="rId2">
+          <a:blip>
             <a:extLst>
               <a:ext uri="{96DAC541-7B7A-43D3-8B79-37D633B846F1}">
-                <asvg:svgBlip xmlns:asvg="http://schemas.microsoft.com/office/drawing/2016/SVG/main" r:embed="rId3"/>
+                <asvg:svgBlip xmlns:asvg="http://schemas.microsoft.com/office/drawing/2016/SVG/main" r:embed="rId2"/>
               </a:ext>
             </a:extLst>
           </a:blip>
@@ -6677,10 +6564,10 @@
           <p:nvPr/>
         </p:nvPicPr>
         <p:blipFill>
-          <a:blip r:embed="rId4">
+          <a:blip>
             <a:extLst>
               <a:ext uri="{96DAC541-7B7A-43D3-8B79-37D633B846F1}">
-                <asvg:svgBlip xmlns:asvg="http://schemas.microsoft.com/office/drawing/2016/SVG/main" r:embed="rId5"/>
+                <asvg:svgBlip xmlns:asvg="http://schemas.microsoft.com/office/drawing/2016/SVG/main" r:embed="rId3"/>
               </a:ext>
             </a:extLst>
           </a:blip>
@@ -6713,10 +6600,10 @@
           <p:nvPr/>
         </p:nvPicPr>
         <p:blipFill>
-          <a:blip r:embed="rId4">
+          <a:blip>
             <a:extLst>
               <a:ext uri="{96DAC541-7B7A-43D3-8B79-37D633B846F1}">
-                <asvg:svgBlip xmlns:asvg="http://schemas.microsoft.com/office/drawing/2016/SVG/main" r:embed="rId5"/>
+                <asvg:svgBlip xmlns:asvg="http://schemas.microsoft.com/office/drawing/2016/SVG/main" r:embed="rId3"/>
               </a:ext>
             </a:extLst>
           </a:blip>
@@ -7245,10 +7132,10 @@
           <p:nvPr/>
         </p:nvPicPr>
         <p:blipFill>
-          <a:blip r:embed="rId4">
+          <a:blip>
             <a:extLst>
               <a:ext uri="{96DAC541-7B7A-43D3-8B79-37D633B846F1}">
-                <asvg:svgBlip xmlns:asvg="http://schemas.microsoft.com/office/drawing/2016/SVG/main" r:embed="rId5"/>
+                <asvg:svgBlip xmlns:asvg="http://schemas.microsoft.com/office/drawing/2016/SVG/main" r:embed="rId3"/>
               </a:ext>
             </a:extLst>
           </a:blip>
@@ -7281,10 +7168,10 @@
           <p:nvPr/>
         </p:nvPicPr>
         <p:blipFill>
-          <a:blip r:embed="rId4">
+          <a:blip>
             <a:extLst>
               <a:ext uri="{96DAC541-7B7A-43D3-8B79-37D633B846F1}">
-                <asvg:svgBlip xmlns:asvg="http://schemas.microsoft.com/office/drawing/2016/SVG/main" r:embed="rId5"/>
+                <asvg:svgBlip xmlns:asvg="http://schemas.microsoft.com/office/drawing/2016/SVG/main" r:embed="rId3"/>
               </a:ext>
             </a:extLst>
           </a:blip>
@@ -7523,10 +7410,10 @@
           <p:nvPr/>
         </p:nvPicPr>
         <p:blipFill>
-          <a:blip r:embed="rId2">
+          <a:blip>
             <a:extLst>
               <a:ext uri="{96DAC541-7B7A-43D3-8B79-37D633B846F1}">
-                <asvg:svgBlip xmlns:asvg="http://schemas.microsoft.com/office/drawing/2016/SVG/main" r:embed="rId3"/>
+                <asvg:svgBlip xmlns:asvg="http://schemas.microsoft.com/office/drawing/2016/SVG/main" r:embed="rId2"/>
               </a:ext>
             </a:extLst>
           </a:blip>
@@ -7651,10 +7538,10 @@
           <p:nvPr/>
         </p:nvPicPr>
         <p:blipFill>
-          <a:blip r:embed="rId4">
+          <a:blip>
             <a:extLst>
               <a:ext uri="{96DAC541-7B7A-43D3-8B79-37D633B846F1}">
-                <asvg:svgBlip xmlns:asvg="http://schemas.microsoft.com/office/drawing/2016/SVG/main" r:embed="rId5"/>
+                <asvg:svgBlip xmlns:asvg="http://schemas.microsoft.com/office/drawing/2016/SVG/main" r:embed="rId3"/>
               </a:ext>
             </a:extLst>
           </a:blip>
@@ -7687,10 +7574,10 @@
           <p:nvPr/>
         </p:nvPicPr>
         <p:blipFill>
-          <a:blip r:embed="rId4">
+          <a:blip>
             <a:extLst>
               <a:ext uri="{96DAC541-7B7A-43D3-8B79-37D633B846F1}">
-                <asvg:svgBlip xmlns:asvg="http://schemas.microsoft.com/office/drawing/2016/SVG/main" r:embed="rId5"/>
+                <asvg:svgBlip xmlns:asvg="http://schemas.microsoft.com/office/drawing/2016/SVG/main" r:embed="rId3"/>
               </a:ext>
             </a:extLst>
           </a:blip>
@@ -8231,10 +8118,10 @@
           <p:nvPr/>
         </p:nvPicPr>
         <p:blipFill>
-          <a:blip r:embed="rId4">
+          <a:blip>
             <a:extLst>
               <a:ext uri="{96DAC541-7B7A-43D3-8B79-37D633B846F1}">
-                <asvg:svgBlip xmlns:asvg="http://schemas.microsoft.com/office/drawing/2016/SVG/main" r:embed="rId5"/>
+                <asvg:svgBlip xmlns:asvg="http://schemas.microsoft.com/office/drawing/2016/SVG/main" r:embed="rId3"/>
               </a:ext>
             </a:extLst>
           </a:blip>
@@ -8267,10 +8154,10 @@
           <p:nvPr/>
         </p:nvPicPr>
         <p:blipFill>
-          <a:blip r:embed="rId4">
+          <a:blip>
             <a:extLst>
               <a:ext uri="{96DAC541-7B7A-43D3-8B79-37D633B846F1}">
-                <asvg:svgBlip xmlns:asvg="http://schemas.microsoft.com/office/drawing/2016/SVG/main" r:embed="rId5"/>
+                <asvg:svgBlip xmlns:asvg="http://schemas.microsoft.com/office/drawing/2016/SVG/main" r:embed="rId3"/>
               </a:ext>
             </a:extLst>
           </a:blip>
@@ -8471,10 +8358,10 @@
           <p:nvPr/>
         </p:nvPicPr>
         <p:blipFill>
-          <a:blip r:embed="rId6">
+          <a:blip>
             <a:extLst>
               <a:ext uri="{96DAC541-7B7A-43D3-8B79-37D633B846F1}">
-                <asvg:svgBlip xmlns:asvg="http://schemas.microsoft.com/office/drawing/2016/SVG/main" r:embed="rId7"/>
+                <asvg:svgBlip xmlns:asvg="http://schemas.microsoft.com/office/drawing/2016/SVG/main" r:embed="rId4"/>
               </a:ext>
             </a:extLst>
           </a:blip>
@@ -8597,10 +8484,10 @@
           <p:nvPr/>
         </p:nvPicPr>
         <p:blipFill>
-          <a:blip r:embed="rId8">
+          <a:blip>
             <a:extLst>
               <a:ext uri="{96DAC541-7B7A-43D3-8B79-37D633B846F1}">
-                <asvg:svgBlip xmlns:asvg="http://schemas.microsoft.com/office/drawing/2016/SVG/main" r:embed="rId9"/>
+                <asvg:svgBlip xmlns:asvg="http://schemas.microsoft.com/office/drawing/2016/SVG/main" r:embed="rId5"/>
               </a:ext>
             </a:extLst>
           </a:blip>
@@ -8784,10 +8671,10 @@
           <p:nvPr/>
         </p:nvPicPr>
         <p:blipFill>
-          <a:blip r:embed="rId10">
+          <a:blip>
             <a:extLst>
               <a:ext uri="{96DAC541-7B7A-43D3-8B79-37D633B846F1}">
-                <asvg:svgBlip xmlns:asvg="http://schemas.microsoft.com/office/drawing/2016/SVG/main" r:embed="rId11"/>
+                <asvg:svgBlip xmlns:asvg="http://schemas.microsoft.com/office/drawing/2016/SVG/main" r:embed="rId6"/>
               </a:ext>
             </a:extLst>
           </a:blip>
@@ -8820,10 +8707,10 @@
           <p:nvPr/>
         </p:nvPicPr>
         <p:blipFill>
-          <a:blip r:embed="rId10">
+          <a:blip>
             <a:extLst>
               <a:ext uri="{96DAC541-7B7A-43D3-8B79-37D633B846F1}">
-                <asvg:svgBlip xmlns:asvg="http://schemas.microsoft.com/office/drawing/2016/SVG/main" r:embed="rId11"/>
+                <asvg:svgBlip xmlns:asvg="http://schemas.microsoft.com/office/drawing/2016/SVG/main" r:embed="rId6"/>
               </a:ext>
             </a:extLst>
           </a:blip>
@@ -9015,10 +8902,10 @@
           <p:nvPr/>
         </p:nvPicPr>
         <p:blipFill>
-          <a:blip r:embed="rId2">
+          <a:blip>
             <a:extLst>
               <a:ext uri="{96DAC541-7B7A-43D3-8B79-37D633B846F1}">
-                <asvg:svgBlip xmlns:asvg="http://schemas.microsoft.com/office/drawing/2016/SVG/main" r:embed="rId3"/>
+                <asvg:svgBlip xmlns:asvg="http://schemas.microsoft.com/office/drawing/2016/SVG/main" r:embed="rId2"/>
               </a:ext>
             </a:extLst>
           </a:blip>
@@ -9269,10 +9156,10 @@
           <p:nvPr/>
         </p:nvPicPr>
         <p:blipFill>
-          <a:blip r:embed="rId4">
+          <a:blip>
             <a:extLst>
               <a:ext uri="{96DAC541-7B7A-43D3-8B79-37D633B846F1}">
-                <asvg:svgBlip xmlns:asvg="http://schemas.microsoft.com/office/drawing/2016/SVG/main" r:embed="rId5"/>
+                <asvg:svgBlip xmlns:asvg="http://schemas.microsoft.com/office/drawing/2016/SVG/main" r:embed="rId3"/>
               </a:ext>
             </a:extLst>
           </a:blip>
@@ -9395,10 +9282,10 @@
           <p:nvPr/>
         </p:nvPicPr>
         <p:blipFill>
-          <a:blip r:embed="rId6">
+          <a:blip>
             <a:extLst>
               <a:ext uri="{96DAC541-7B7A-43D3-8B79-37D633B846F1}">
-                <asvg:svgBlip xmlns:asvg="http://schemas.microsoft.com/office/drawing/2016/SVG/main" r:embed="rId7"/>
+                <asvg:svgBlip xmlns:asvg="http://schemas.microsoft.com/office/drawing/2016/SVG/main" r:embed="rId4"/>
               </a:ext>
             </a:extLst>
           </a:blip>
@@ -9582,10 +9469,10 @@
           <p:nvPr/>
         </p:nvPicPr>
         <p:blipFill>
-          <a:blip r:embed="rId8">
+          <a:blip>
             <a:extLst>
               <a:ext uri="{96DAC541-7B7A-43D3-8B79-37D633B846F1}">
-                <asvg:svgBlip xmlns:asvg="http://schemas.microsoft.com/office/drawing/2016/SVG/main" r:embed="rId9"/>
+                <asvg:svgBlip xmlns:asvg="http://schemas.microsoft.com/office/drawing/2016/SVG/main" r:embed="rId5"/>
               </a:ext>
             </a:extLst>
           </a:blip>
@@ -9618,10 +9505,10 @@
           <p:nvPr/>
         </p:nvPicPr>
         <p:blipFill>
-          <a:blip r:embed="rId8">
+          <a:blip>
             <a:extLst>
               <a:ext uri="{96DAC541-7B7A-43D3-8B79-37D633B846F1}">
-                <asvg:svgBlip xmlns:asvg="http://schemas.microsoft.com/office/drawing/2016/SVG/main" r:embed="rId9"/>
+                <asvg:svgBlip xmlns:asvg="http://schemas.microsoft.com/office/drawing/2016/SVG/main" r:embed="rId5"/>
               </a:ext>
             </a:extLst>
           </a:blip>

</xml_diff>